<commit_message>
update buoi 3 part 2
</commit_message>
<xml_diff>
--- a/Bài Giảng/Buổi 1/Part 2 buổi 1.pptx
+++ b/Bài Giảng/Buổi 1/Part 2 buổi 1.pptx
@@ -5,10 +5,10 @@
     <p:sldMasterId id="2147483658" r:id="rId1"/>
   </p:sldMasterIdLst>
   <p:notesMasterIdLst>
-    <p:notesMasterId r:id="rId8"/>
+    <p:notesMasterId r:id="rId9"/>
   </p:notesMasterIdLst>
   <p:handoutMasterIdLst>
-    <p:handoutMasterId r:id="rId9"/>
+    <p:handoutMasterId r:id="rId10"/>
   </p:handoutMasterIdLst>
   <p:sldIdLst>
     <p:sldId id="265" r:id="rId2"/>
@@ -17,6 +17,7 @@
     <p:sldId id="270" r:id="rId5"/>
     <p:sldId id="277" r:id="rId6"/>
     <p:sldId id="278" r:id="rId7"/>
+    <p:sldId id="279" r:id="rId8"/>
   </p:sldIdLst>
   <p:sldSz cx="9144000" cy="6858000" type="screen4x3"/>
   <p:notesSz cx="6858000" cy="9144000"/>
@@ -123,6 +124,32 @@
 </p:presentation>
 </file>
 
+<file path=ppt/commentAuthors.xml><?xml version="1.0" encoding="utf-8"?>
+<p:cmAuthorLst xmlns:a="http://schemas.openxmlformats.org/drawingml/2006/main" xmlns:r="http://schemas.openxmlformats.org/officeDocument/2006/relationships" xmlns:p="http://schemas.openxmlformats.org/presentationml/2006/main">
+  <p:cmAuthor id="1" name="Thắng Hữu" initials="TH" lastIdx="1" clrIdx="0">
+    <p:extLst>
+      <p:ext uri="{19B8F6BF-5375-455C-9EA6-DF929625EA0E}">
+        <p15:presenceInfo xmlns:p15="http://schemas.microsoft.com/office/powerpoint/2012/main" userId="1ace0c489eb93fb0" providerId="Windows Live"/>
+      </p:ext>
+    </p:extLst>
+  </p:cmAuthor>
+</p:cmAuthorLst>
+</file>
+
+<file path=ppt/comments/comment1.xml><?xml version="1.0" encoding="utf-8"?>
+<p:cmLst xmlns:a="http://schemas.openxmlformats.org/drawingml/2006/main" xmlns:r="http://schemas.openxmlformats.org/officeDocument/2006/relationships" xmlns:p="http://schemas.openxmlformats.org/presentationml/2006/main">
+  <p:cm authorId="1" dt="2025-08-23T14:29:57.685" idx="1">
+    <p:pos x="10" y="10"/>
+    <p:text/>
+    <p:extLst>
+      <p:ext uri="{C676402C-5697-4E1C-873F-D02D1690AC5C}">
+        <p15:threadingInfo xmlns:p15="http://schemas.microsoft.com/office/powerpoint/2012/main" timeZoneBias="-420"/>
+      </p:ext>
+    </p:extLst>
+  </p:cm>
+</p:cmLst>
+</file>
+
 <file path=ppt/handoutMasters/handoutMaster1.xml><?xml version="1.0" encoding="utf-8"?>
 <p:handoutMaster xmlns:a="http://schemas.openxmlformats.org/drawingml/2006/main" xmlns:r="http://schemas.openxmlformats.org/officeDocument/2006/relationships" xmlns:p="http://schemas.openxmlformats.org/presentationml/2006/main">
   <p:cSld>
@@ -217,7 +244,7 @@
           <a:p>
             <a:fld id="{48B45424-6BAC-416C-8F6C-5F9DE854A36B}" type="datetimeFigureOut">
               <a:rPr lang="en-US" smtClean="0"/>
-              <a:t>8/19/2025</a:t>
+              <a:t>8/23/2025</a:t>
             </a:fld>
             <a:endParaRPr lang="en-US"/>
           </a:p>
@@ -395,7 +422,7 @@
           <a:p>
             <a:fld id="{6B733702-C25A-40B9-9167-54BAA79B29B0}" type="datetimeFigureOut">
               <a:rPr lang="en-US" smtClean="0"/>
-              <a:t>8/19/2025</a:t>
+              <a:t>8/23/2025</a:t>
             </a:fld>
             <a:endParaRPr lang="en-US"/>
           </a:p>
@@ -663,6 +690,605 @@
 </p:notesMaster>
 </file>
 
+<file path=ppt/notesSlides/notesSlide1.xml><?xml version="1.0" encoding="utf-8"?>
+<p:notes xmlns:a="http://schemas.openxmlformats.org/drawingml/2006/main" xmlns:r="http://schemas.openxmlformats.org/officeDocument/2006/relationships" xmlns:p="http://schemas.openxmlformats.org/presentationml/2006/main">
+  <p:cSld>
+    <p:spTree>
+      <p:nvGrpSpPr>
+        <p:cNvPr id="1" name=""/>
+        <p:cNvGrpSpPr/>
+        <p:nvPr/>
+      </p:nvGrpSpPr>
+      <p:grpSpPr>
+        <a:xfrm>
+          <a:off x="0" y="0"/>
+          <a:ext cx="0" cy="0"/>
+          <a:chOff x="0" y="0"/>
+          <a:chExt cx="0" cy="0"/>
+        </a:xfrm>
+      </p:grpSpPr>
+      <p:sp>
+        <p:nvSpPr>
+          <p:cNvPr id="2" name="Slide Image Placeholder 1"/>
+          <p:cNvSpPr>
+            <a:spLocks noGrp="1" noRot="1" noChangeAspect="1"/>
+          </p:cNvSpPr>
+          <p:nvPr>
+            <p:ph type="sldImg"/>
+          </p:nvPr>
+        </p:nvSpPr>
+        <p:spPr/>
+      </p:sp>
+      <p:sp>
+        <p:nvSpPr>
+          <p:cNvPr id="3" name="Notes Placeholder 2"/>
+          <p:cNvSpPr>
+            <a:spLocks noGrp="1"/>
+          </p:cNvSpPr>
+          <p:nvPr>
+            <p:ph type="body" idx="1"/>
+          </p:nvPr>
+        </p:nvSpPr>
+        <p:spPr/>
+        <p:txBody>
+          <a:bodyPr/>
+          <a:lstStyle/>
+          <a:p>
+            <a:r>
+              <a:rPr lang="vi-VN" b="1" dirty="0"/>
+              <a:t>Tụ điện</a:t>
+            </a:r>
+            <a:r>
+              <a:rPr lang="vi-VN" dirty="0"/>
+              <a:t> là linh kiện có hai chân, hoạt động giống như một cái bình chứa điện. Nó tích trữ năng lượng điện dưới dạng </a:t>
+            </a:r>
+            <a:r>
+              <a:rPr lang="vi-VN" b="1" dirty="0"/>
+              <a:t>điện trường</a:t>
+            </a:r>
+          </a:p>
+          <a:p>
+            <a:r>
+              <a:rPr lang="vi-VN" b="1" dirty="0"/>
+              <a:t>Tích trữ và phóng điện</a:t>
+            </a:r>
+            <a:r>
+              <a:rPr lang="vi-VN" dirty="0"/>
+              <a:t>: giống như pin mini nhưng phóng rất nhanh.</a:t>
+            </a:r>
+          </a:p>
+          <a:p>
+            <a:r>
+              <a:rPr lang="vi-VN" b="1" dirty="0"/>
+              <a:t>Lọc nhiễu</a:t>
+            </a:r>
+            <a:r>
+              <a:rPr lang="vi-VN" dirty="0"/>
+              <a:t>: trong mạch nguồn, tụ giúp làm điện áp mượt hơn, không bị gợn sóng.</a:t>
+            </a:r>
+          </a:p>
+          <a:p>
+            <a:r>
+              <a:rPr lang="vi-VN" b="1" dirty="0"/>
+              <a:t>Tạo trễ</a:t>
+            </a:r>
+            <a:r>
+              <a:rPr lang="vi-VN" dirty="0"/>
+              <a:t>: ví dụ khi kết hợp với điện trở, tụ có thể tạo ra khoảng trễ cho mạch bật tắt đèn.</a:t>
+            </a:r>
+          </a:p>
+          <a:p>
+            <a:r>
+              <a:rPr lang="vi-VN" b="1" dirty="0"/>
+              <a:t>Tụ hóa</a:t>
+            </a:r>
+            <a:r>
+              <a:rPr lang="vi-VN" dirty="0"/>
+              <a:t>: thường hình trụ, to hơn, có cực âm và dương rõ ràng. Nếu cắm ngược sẽ hỏng, thậm chí nổ.</a:t>
+            </a:r>
+          </a:p>
+          <a:p>
+            <a:r>
+              <a:rPr lang="vi-VN" b="1" dirty="0"/>
+              <a:t>Tụ gốm</a:t>
+            </a:r>
+            <a:r>
+              <a:rPr lang="vi-VN" dirty="0"/>
+              <a:t>: nhỏ, thường màu cam/nâu, không phân cực nên cắm chiều nào cũng được.</a:t>
+            </a:r>
+          </a:p>
+          <a:p>
+            <a:endParaRPr lang="vi-VN" dirty="0"/>
+          </a:p>
+        </p:txBody>
+      </p:sp>
+      <p:sp>
+        <p:nvSpPr>
+          <p:cNvPr id="4" name="Slide Number Placeholder 3"/>
+          <p:cNvSpPr>
+            <a:spLocks noGrp="1"/>
+          </p:cNvSpPr>
+          <p:nvPr>
+            <p:ph type="sldNum" sz="quarter" idx="5"/>
+          </p:nvPr>
+        </p:nvSpPr>
+        <p:spPr/>
+        <p:txBody>
+          <a:bodyPr/>
+          <a:lstStyle/>
+          <a:p>
+            <a:fld id="{AB2FC7A4-3D1B-482D-8C9D-7642A2CE3076}" type="slidenum">
+              <a:rPr lang="en-US" smtClean="0"/>
+              <a:t>2</a:t>
+            </a:fld>
+            <a:endParaRPr lang="en-US"/>
+          </a:p>
+        </p:txBody>
+      </p:sp>
+    </p:spTree>
+    <p:extLst>
+      <p:ext uri="{BB962C8B-B14F-4D97-AF65-F5344CB8AC3E}">
+        <p14:creationId xmlns:p14="http://schemas.microsoft.com/office/powerpoint/2010/main" val="1061958441"/>
+      </p:ext>
+    </p:extLst>
+  </p:cSld>
+  <p:clrMapOvr>
+    <a:masterClrMapping/>
+  </p:clrMapOvr>
+</p:notes>
+</file>
+
+<file path=ppt/notesSlides/notesSlide2.xml><?xml version="1.0" encoding="utf-8"?>
+<p:notes xmlns:a="http://schemas.openxmlformats.org/drawingml/2006/main" xmlns:r="http://schemas.openxmlformats.org/officeDocument/2006/relationships" xmlns:p="http://schemas.openxmlformats.org/presentationml/2006/main">
+  <p:cSld>
+    <p:spTree>
+      <p:nvGrpSpPr>
+        <p:cNvPr id="1" name=""/>
+        <p:cNvGrpSpPr/>
+        <p:nvPr/>
+      </p:nvGrpSpPr>
+      <p:grpSpPr>
+        <a:xfrm>
+          <a:off x="0" y="0"/>
+          <a:ext cx="0" cy="0"/>
+          <a:chOff x="0" y="0"/>
+          <a:chExt cx="0" cy="0"/>
+        </a:xfrm>
+      </p:grpSpPr>
+      <p:sp>
+        <p:nvSpPr>
+          <p:cNvPr id="2" name="Slide Image Placeholder 1"/>
+          <p:cNvSpPr>
+            <a:spLocks noGrp="1" noRot="1" noChangeAspect="1"/>
+          </p:cNvSpPr>
+          <p:nvPr>
+            <p:ph type="sldImg"/>
+          </p:nvPr>
+        </p:nvSpPr>
+        <p:spPr/>
+      </p:sp>
+      <p:sp>
+        <p:nvSpPr>
+          <p:cNvPr id="3" name="Notes Placeholder 2"/>
+          <p:cNvSpPr>
+            <a:spLocks noGrp="1"/>
+          </p:cNvSpPr>
+          <p:nvPr>
+            <p:ph type="body" idx="1"/>
+          </p:nvPr>
+        </p:nvSpPr>
+        <p:spPr/>
+        <p:txBody>
+          <a:bodyPr/>
+          <a:lstStyle/>
+          <a:p>
+            <a:r>
+              <a:rPr lang="vi-VN" b="1" dirty="0"/>
+              <a:t>Cuộn cảm</a:t>
+            </a:r>
+            <a:r>
+              <a:rPr lang="vi-VN" dirty="0"/>
+              <a:t> thực chất là một cuộn dây đồng quấn quanh lõi sắt hoặc lõi không khí. Khi có dòng điện chạy qua, nó sinh ra </a:t>
+            </a:r>
+            <a:r>
+              <a:rPr lang="vi-VN" b="1" dirty="0"/>
+              <a:t>từ trường</a:t>
+            </a:r>
+          </a:p>
+          <a:p>
+            <a:r>
+              <a:rPr lang="vi-VN" dirty="0"/>
+              <a:t>Đặc tính quan trọng của cuộn cảm là </a:t>
+            </a:r>
+            <a:r>
+              <a:rPr lang="vi-VN" b="1" dirty="0"/>
+              <a:t>chống lại sự thay đổi của dòng điện</a:t>
+            </a:r>
+            <a:r>
+              <a:rPr lang="vi-VN" dirty="0"/>
+              <a:t>. Nghĩa là nếu dòng điện tăng hoặc giảm đột ngột, cuộn cảm sẽ tìm cách giữ cho dòng điện ổn định hơn.</a:t>
+            </a:r>
+          </a:p>
+          <a:p>
+            <a:r>
+              <a:rPr lang="vi-VN" dirty="0"/>
+              <a:t>Ứng dụng thực tế:</a:t>
+            </a:r>
+          </a:p>
+          <a:p>
+            <a:r>
+              <a:rPr lang="vi-VN" dirty="0"/>
+              <a:t>Trong sơ đồ mạch, cuộn cảm được ký hiệu bằng hình lò xo</a:t>
+            </a:r>
+          </a:p>
+        </p:txBody>
+      </p:sp>
+      <p:sp>
+        <p:nvSpPr>
+          <p:cNvPr id="4" name="Slide Number Placeholder 3"/>
+          <p:cNvSpPr>
+            <a:spLocks noGrp="1"/>
+          </p:cNvSpPr>
+          <p:nvPr>
+            <p:ph type="sldNum" sz="quarter" idx="5"/>
+          </p:nvPr>
+        </p:nvSpPr>
+        <p:spPr/>
+        <p:txBody>
+          <a:bodyPr/>
+          <a:lstStyle/>
+          <a:p>
+            <a:fld id="{AB2FC7A4-3D1B-482D-8C9D-7642A2CE3076}" type="slidenum">
+              <a:rPr lang="en-US" smtClean="0"/>
+              <a:t>3</a:t>
+            </a:fld>
+            <a:endParaRPr lang="en-US"/>
+          </a:p>
+        </p:txBody>
+      </p:sp>
+    </p:spTree>
+    <p:extLst>
+      <p:ext uri="{BB962C8B-B14F-4D97-AF65-F5344CB8AC3E}">
+        <p14:creationId xmlns:p14="http://schemas.microsoft.com/office/powerpoint/2010/main" val="3529997185"/>
+      </p:ext>
+    </p:extLst>
+  </p:cSld>
+  <p:clrMapOvr>
+    <a:masterClrMapping/>
+  </p:clrMapOvr>
+</p:notes>
+</file>
+
+<file path=ppt/notesSlides/notesSlide3.xml><?xml version="1.0" encoding="utf-8"?>
+<p:notes xmlns:a="http://schemas.openxmlformats.org/drawingml/2006/main" xmlns:r="http://schemas.openxmlformats.org/officeDocument/2006/relationships" xmlns:p="http://schemas.openxmlformats.org/presentationml/2006/main">
+  <p:cSld>
+    <p:spTree>
+      <p:nvGrpSpPr>
+        <p:cNvPr id="1" name=""/>
+        <p:cNvGrpSpPr/>
+        <p:nvPr/>
+      </p:nvGrpSpPr>
+      <p:grpSpPr>
+        <a:xfrm>
+          <a:off x="0" y="0"/>
+          <a:ext cx="0" cy="0"/>
+          <a:chOff x="0" y="0"/>
+          <a:chExt cx="0" cy="0"/>
+        </a:xfrm>
+      </p:grpSpPr>
+      <p:sp>
+        <p:nvSpPr>
+          <p:cNvPr id="2" name="Slide Image Placeholder 1"/>
+          <p:cNvSpPr>
+            <a:spLocks noGrp="1" noRot="1" noChangeAspect="1"/>
+          </p:cNvSpPr>
+          <p:nvPr>
+            <p:ph type="sldImg"/>
+          </p:nvPr>
+        </p:nvSpPr>
+        <p:spPr/>
+      </p:sp>
+      <p:sp>
+        <p:nvSpPr>
+          <p:cNvPr id="3" name="Notes Placeholder 2"/>
+          <p:cNvSpPr>
+            <a:spLocks noGrp="1"/>
+          </p:cNvSpPr>
+          <p:nvPr>
+            <p:ph type="body" idx="1"/>
+          </p:nvPr>
+        </p:nvSpPr>
+        <p:spPr/>
+        <p:txBody>
+          <a:bodyPr/>
+          <a:lstStyle/>
+          <a:p>
+            <a:r>
+              <a:rPr lang="vi-VN" dirty="0"/>
+              <a:t>Transistor có 3 chân:</a:t>
+            </a:r>
+          </a:p>
+          <a:p>
+            <a:pPr>
+              <a:buFont typeface="Arial" panose="020B0604020202020204" pitchFamily="34" charset="0"/>
+              <a:buChar char="•"/>
+            </a:pPr>
+            <a:r>
+              <a:rPr lang="vi-VN" b="1" dirty="0"/>
+              <a:t>B (Base – gốc)</a:t>
+            </a:r>
+            <a:r>
+              <a:rPr lang="vi-VN" dirty="0"/>
+              <a:t>: chân điều khiển.</a:t>
+            </a:r>
+          </a:p>
+          <a:p>
+            <a:pPr>
+              <a:buFont typeface="Arial" panose="020B0604020202020204" pitchFamily="34" charset="0"/>
+              <a:buChar char="•"/>
+            </a:pPr>
+            <a:r>
+              <a:rPr lang="vi-VN" b="1" dirty="0"/>
+              <a:t>C (Collector – cực thu)</a:t>
+            </a:r>
+            <a:r>
+              <a:rPr lang="vi-VN" dirty="0"/>
+              <a:t>: nơi dòng điện đi vào.</a:t>
+            </a:r>
+          </a:p>
+          <a:p>
+            <a:pPr>
+              <a:buFont typeface="Arial" panose="020B0604020202020204" pitchFamily="34" charset="0"/>
+              <a:buChar char="•"/>
+            </a:pPr>
+            <a:r>
+              <a:rPr lang="vi-VN" b="1" dirty="0"/>
+              <a:t>E (Emitter – cực phát)</a:t>
+            </a:r>
+            <a:r>
+              <a:rPr lang="vi-VN" dirty="0"/>
+              <a:t>: nơi dòng điện đi ra.</a:t>
+            </a:r>
+          </a:p>
+          <a:p>
+            <a:r>
+              <a:rPr lang="vi-VN" dirty="0"/>
+              <a:t>Có hai loại:</a:t>
+            </a:r>
+          </a:p>
+          <a:p>
+            <a:pPr>
+              <a:buFont typeface="Arial" panose="020B0604020202020204" pitchFamily="34" charset="0"/>
+              <a:buChar char="•"/>
+            </a:pPr>
+            <a:r>
+              <a:rPr lang="vi-VN" b="1" dirty="0"/>
+              <a:t>NPN</a:t>
+            </a:r>
+            <a:r>
+              <a:rPr lang="vi-VN" dirty="0"/>
+              <a:t>: phổ biến hơn, khi có dòng nhỏ vào Base, transistor cho dòng lớn đi từ C sang E.</a:t>
+            </a:r>
+          </a:p>
+          <a:p>
+            <a:pPr>
+              <a:buFont typeface="Arial" panose="020B0604020202020204" pitchFamily="34" charset="0"/>
+              <a:buChar char="•"/>
+            </a:pPr>
+            <a:r>
+              <a:rPr lang="vi-VN" b="1" dirty="0"/>
+              <a:t>PNP</a:t>
+            </a:r>
+            <a:r>
+              <a:rPr lang="vi-VN" dirty="0"/>
+              <a:t>: ngược lại, dòng đi theo chiều khác.</a:t>
+            </a:r>
+          </a:p>
+          <a:p>
+            <a:r>
+              <a:rPr lang="vi-VN" dirty="0"/>
+              <a:t>Ứng dụng:</a:t>
+            </a:r>
+          </a:p>
+          <a:p>
+            <a:pPr>
+              <a:buFont typeface="+mj-lt"/>
+              <a:buAutoNum type="arabicPeriod"/>
+            </a:pPr>
+            <a:r>
+              <a:rPr lang="vi-VN" b="1" dirty="0"/>
+              <a:t>Làm công tắc điện tử</a:t>
+            </a:r>
+            <a:r>
+              <a:rPr lang="vi-VN" dirty="0"/>
+              <a:t>: ví dụ tín hiệu nhỏ từ Arduino bật LED hoặc quạt.</a:t>
+            </a:r>
+          </a:p>
+          <a:p>
+            <a:pPr>
+              <a:buFont typeface="+mj-lt"/>
+              <a:buAutoNum type="arabicPeriod"/>
+            </a:pPr>
+            <a:r>
+              <a:rPr lang="vi-VN" b="1" dirty="0"/>
+              <a:t>Khuếch đại tín hiệu</a:t>
+            </a:r>
+            <a:r>
+              <a:rPr lang="vi-VN" dirty="0"/>
+              <a:t>: ví dụ trong loa, tín hiệu âm thanh nhỏ được transistor khuếch đại để phát ra loa to.</a:t>
+            </a:r>
+          </a:p>
+          <a:p>
+            <a:r>
+              <a:rPr lang="vi-VN" dirty="0"/>
+              <a:t>transistor có thể khuếch đại dòng điện hàng trăm lần.</a:t>
+            </a:r>
+          </a:p>
+          <a:p>
+            <a:r>
+              <a:rPr lang="vi-VN" i="1" dirty="0"/>
+              <a:t>điều khiển một bóng đèn 220V từ Arduino 5V, thì có dùng transistor được không?</a:t>
+            </a:r>
+            <a:r>
+              <a:rPr lang="vi-VN" dirty="0"/>
+              <a:t> </a:t>
+            </a:r>
+          </a:p>
+        </p:txBody>
+      </p:sp>
+      <p:sp>
+        <p:nvSpPr>
+          <p:cNvPr id="4" name="Slide Number Placeholder 3"/>
+          <p:cNvSpPr>
+            <a:spLocks noGrp="1"/>
+          </p:cNvSpPr>
+          <p:nvPr>
+            <p:ph type="sldNum" sz="quarter" idx="5"/>
+          </p:nvPr>
+        </p:nvSpPr>
+        <p:spPr/>
+        <p:txBody>
+          <a:bodyPr/>
+          <a:lstStyle/>
+          <a:p>
+            <a:fld id="{AB2FC7A4-3D1B-482D-8C9D-7642A2CE3076}" type="slidenum">
+              <a:rPr lang="en-US" smtClean="0"/>
+              <a:t>4</a:t>
+            </a:fld>
+            <a:endParaRPr lang="en-US"/>
+          </a:p>
+        </p:txBody>
+      </p:sp>
+    </p:spTree>
+    <p:extLst>
+      <p:ext uri="{BB962C8B-B14F-4D97-AF65-F5344CB8AC3E}">
+        <p14:creationId xmlns:p14="http://schemas.microsoft.com/office/powerpoint/2010/main" val="1464965613"/>
+      </p:ext>
+    </p:extLst>
+  </p:cSld>
+  <p:clrMapOvr>
+    <a:masterClrMapping/>
+  </p:clrMapOvr>
+</p:notes>
+</file>
+
+<file path=ppt/notesSlides/notesSlide4.xml><?xml version="1.0" encoding="utf-8"?>
+<p:notes xmlns:a="http://schemas.openxmlformats.org/drawingml/2006/main" xmlns:r="http://schemas.openxmlformats.org/officeDocument/2006/relationships" xmlns:p="http://schemas.openxmlformats.org/presentationml/2006/main">
+  <p:cSld>
+    <p:spTree>
+      <p:nvGrpSpPr>
+        <p:cNvPr id="1" name=""/>
+        <p:cNvGrpSpPr/>
+        <p:nvPr/>
+      </p:nvGrpSpPr>
+      <p:grpSpPr>
+        <a:xfrm>
+          <a:off x="0" y="0"/>
+          <a:ext cx="0" cy="0"/>
+          <a:chOff x="0" y="0"/>
+          <a:chExt cx="0" cy="0"/>
+        </a:xfrm>
+      </p:grpSpPr>
+      <p:sp>
+        <p:nvSpPr>
+          <p:cNvPr id="2" name="Slide Image Placeholder 1"/>
+          <p:cNvSpPr>
+            <a:spLocks noGrp="1" noRot="1" noChangeAspect="1"/>
+          </p:cNvSpPr>
+          <p:nvPr>
+            <p:ph type="sldImg"/>
+          </p:nvPr>
+        </p:nvSpPr>
+        <p:spPr/>
+      </p:sp>
+      <p:sp>
+        <p:nvSpPr>
+          <p:cNvPr id="3" name="Notes Placeholder 2"/>
+          <p:cNvSpPr>
+            <a:spLocks noGrp="1"/>
+          </p:cNvSpPr>
+          <p:nvPr>
+            <p:ph type="body" idx="1"/>
+          </p:nvPr>
+        </p:nvSpPr>
+        <p:spPr/>
+        <p:txBody>
+          <a:bodyPr/>
+          <a:lstStyle/>
+          <a:p>
+            <a:r>
+              <a:rPr lang="vi-VN" dirty="0"/>
+              <a:t>Relay là một loại </a:t>
+            </a:r>
+            <a:r>
+              <a:rPr lang="vi-VN" b="1" dirty="0"/>
+              <a:t>công tắc điều khiển bằng điện từ</a:t>
+            </a:r>
+            <a:r>
+              <a:rPr lang="vi-VN" dirty="0"/>
+              <a:t>.</a:t>
+            </a:r>
+            <a:br>
+              <a:rPr lang="vi-VN" dirty="0"/>
+            </a:br>
+            <a:r>
+              <a:rPr lang="vi-VN" dirty="0"/>
+              <a:t>Bên trong relay có một cuộn dây. Khi có dòng chạy qua, cuộn dây tạo từ trường, hút lá kim loại để đóng hoặc mở mạch điện.</a:t>
+            </a:r>
+          </a:p>
+          <a:p>
+            <a:r>
+              <a:rPr lang="vi-VN" dirty="0"/>
+              <a:t>Có thể dùng tín hiệu nhỏ (5V) để điều khiển tải lớn (220V).</a:t>
+            </a:r>
+          </a:p>
+          <a:p>
+            <a:r>
+              <a:rPr lang="vi-VN" dirty="0"/>
+              <a:t>Cách ly giữa mạch điều khiển và mạch tải, giúp an toàn.</a:t>
+            </a:r>
+          </a:p>
+          <a:p>
+            <a:endParaRPr lang="vi-VN" dirty="0"/>
+          </a:p>
+        </p:txBody>
+      </p:sp>
+      <p:sp>
+        <p:nvSpPr>
+          <p:cNvPr id="4" name="Slide Number Placeholder 3"/>
+          <p:cNvSpPr>
+            <a:spLocks noGrp="1"/>
+          </p:cNvSpPr>
+          <p:nvPr>
+            <p:ph type="sldNum" sz="quarter" idx="5"/>
+          </p:nvPr>
+        </p:nvSpPr>
+        <p:spPr/>
+        <p:txBody>
+          <a:bodyPr/>
+          <a:lstStyle/>
+          <a:p>
+            <a:fld id="{AB2FC7A4-3D1B-482D-8C9D-7642A2CE3076}" type="slidenum">
+              <a:rPr lang="en-US" smtClean="0"/>
+              <a:t>5</a:t>
+            </a:fld>
+            <a:endParaRPr lang="en-US"/>
+          </a:p>
+        </p:txBody>
+      </p:sp>
+    </p:spTree>
+    <p:extLst>
+      <p:ext uri="{BB962C8B-B14F-4D97-AF65-F5344CB8AC3E}">
+        <p14:creationId xmlns:p14="http://schemas.microsoft.com/office/powerpoint/2010/main" val="4068687483"/>
+      </p:ext>
+    </p:extLst>
+  </p:cSld>
+  <p:clrMapOvr>
+    <a:masterClrMapping/>
+  </p:clrMapOvr>
+</p:notes>
+</file>
+
 <file path=ppt/slideLayouts/slideLayout1.xml><?xml version="1.0" encoding="utf-8"?>
 <p:sldLayout xmlns:a="http://schemas.openxmlformats.org/drawingml/2006/main" xmlns:r="http://schemas.openxmlformats.org/officeDocument/2006/relationships" xmlns:p="http://schemas.openxmlformats.org/presentationml/2006/main" userDrawn="1">
   <p:cSld name="1_Section Header">
@@ -737,7 +1363,7 @@
             <a:fld id="{F70EAA40-3A53-4A3D-924A-D38F1059C7D5}" type="datetime1">
               <a:rPr lang="en-US" smtClean="0"/>
               <a:pPr/>
-              <a:t>8/19/2025</a:t>
+              <a:t>8/23/2025</a:t>
             </a:fld>
             <a:endParaRPr lang="en-US"/>
           </a:p>
@@ -1071,7 +1697,7 @@
             <a:fld id="{F70EAA40-3A53-4A3D-924A-D38F1059C7D5}" type="datetime1">
               <a:rPr lang="en-US" smtClean="0"/>
               <a:pPr/>
-              <a:t>8/19/2025</a:t>
+              <a:t>8/23/2025</a:t>
             </a:fld>
             <a:endParaRPr lang="en-US"/>
           </a:p>
@@ -1506,7 +2132,7 @@
             <a:fld id="{F70EAA40-3A53-4A3D-924A-D38F1059C7D5}" type="datetime1">
               <a:rPr lang="en-US" smtClean="0"/>
               <a:pPr/>
-              <a:t>8/19/2025</a:t>
+              <a:t>8/23/2025</a:t>
             </a:fld>
             <a:endParaRPr lang="en-US"/>
           </a:p>
@@ -1840,7 +2466,7 @@
             <a:fld id="{F70EAA40-3A53-4A3D-924A-D38F1059C7D5}" type="datetime1">
               <a:rPr lang="en-US" smtClean="0"/>
               <a:pPr/>
-              <a:t>8/19/2025</a:t>
+              <a:t>8/23/2025</a:t>
             </a:fld>
             <a:endParaRPr lang="en-US"/>
           </a:p>
@@ -2526,7 +3152,7 @@
             <a:fld id="{F70EAA40-3A53-4A3D-924A-D38F1059C7D5}" type="datetime1">
               <a:rPr lang="en-US" smtClean="0"/>
               <a:pPr/>
-              <a:t>8/19/2025</a:t>
+              <a:t>8/23/2025</a:t>
             </a:fld>
             <a:endParaRPr lang="en-US"/>
           </a:p>
@@ -2716,7 +3342,7 @@
             <a:fld id="{F70EAA40-3A53-4A3D-924A-D38F1059C7D5}" type="datetime1">
               <a:rPr lang="en-US" smtClean="0"/>
               <a:pPr/>
-              <a:t>8/19/2025</a:t>
+              <a:t>8/23/2025</a:t>
             </a:fld>
             <a:endParaRPr lang="en-US"/>
           </a:p>
@@ -3299,7 +3925,7 @@
             <a:fld id="{F70EAA40-3A53-4A3D-924A-D38F1059C7D5}" type="datetime1">
               <a:rPr lang="en-US" smtClean="0"/>
               <a:pPr/>
-              <a:t>8/19/2025</a:t>
+              <a:t>8/23/2025</a:t>
             </a:fld>
             <a:endParaRPr lang="en-US"/>
           </a:p>
@@ -3485,7 +4111,7 @@
             <a:fld id="{F70EAA40-3A53-4A3D-924A-D38F1059C7D5}" type="datetime1">
               <a:rPr lang="en-US" smtClean="0"/>
               <a:pPr/>
-              <a:t>8/19/2025</a:t>
+              <a:t>8/23/2025</a:t>
             </a:fld>
             <a:endParaRPr lang="en-US"/>
           </a:p>
@@ -4360,6 +4986,18 @@
   <p:clrMapOvr>
     <a:masterClrMapping/>
   </p:clrMapOvr>
+  <mc:AlternateContent xmlns:mc="http://schemas.openxmlformats.org/markup-compatibility/2006" xmlns:p159="http://schemas.microsoft.com/office/powerpoint/2015/09/main">
+    <mc:Choice Requires="p159">
+      <p:transition xmlns:p14="http://schemas.microsoft.com/office/powerpoint/2010/main" spd="slow" p14:dur="2000">
+        <p159:morph option="byObject"/>
+      </p:transition>
+    </mc:Choice>
+    <mc:Fallback xmlns="">
+      <p:transition spd="slow">
+        <p:fade/>
+      </p:transition>
+    </mc:Fallback>
+  </mc:AlternateContent>
 </p:sld>
 </file>
 
@@ -4806,7 +5444,7 @@
           <p:nvPr/>
         </p:nvPicPr>
         <p:blipFill>
-          <a:blip r:embed="rId2"/>
+          <a:blip r:embed="rId3"/>
           <a:stretch>
             <a:fillRect/>
           </a:stretch>
@@ -4836,7 +5474,7 @@
           <p:nvPr/>
         </p:nvPicPr>
         <p:blipFill>
-          <a:blip r:embed="rId3"/>
+          <a:blip r:embed="rId4"/>
           <a:stretch>
             <a:fillRect/>
           </a:stretch>
@@ -4866,7 +5504,7 @@
           <p:nvPr/>
         </p:nvPicPr>
         <p:blipFill>
-          <a:blip r:embed="rId4"/>
+          <a:blip r:embed="rId5"/>
           <a:stretch>
             <a:fillRect/>
           </a:stretch>
@@ -4891,6 +5529,18 @@
   <p:clrMapOvr>
     <a:masterClrMapping/>
   </p:clrMapOvr>
+  <mc:AlternateContent xmlns:mc="http://schemas.openxmlformats.org/markup-compatibility/2006" xmlns:p159="http://schemas.microsoft.com/office/powerpoint/2015/09/main">
+    <mc:Choice Requires="p159">
+      <p:transition xmlns:p14="http://schemas.microsoft.com/office/powerpoint/2010/main" spd="slow" p14:dur="2000">
+        <p159:morph option="byObject"/>
+      </p:transition>
+    </mc:Choice>
+    <mc:Fallback xmlns="">
+      <p:transition spd="slow">
+        <p:fade/>
+      </p:transition>
+    </mc:Fallback>
+  </mc:AlternateContent>
 </p:sld>
 </file>
 
@@ -5254,7 +5904,7 @@
           <p:nvPr/>
         </p:nvPicPr>
         <p:blipFill>
-          <a:blip r:embed="rId2"/>
+          <a:blip r:embed="rId3"/>
           <a:stretch>
             <a:fillRect/>
           </a:stretch>
@@ -5284,7 +5934,7 @@
           <p:nvPr/>
         </p:nvPicPr>
         <p:blipFill>
-          <a:blip r:embed="rId3"/>
+          <a:blip r:embed="rId4"/>
           <a:stretch>
             <a:fillRect/>
           </a:stretch>
@@ -5309,6 +5959,18 @@
   <p:clrMapOvr>
     <a:masterClrMapping/>
   </p:clrMapOvr>
+  <mc:AlternateContent xmlns:mc="http://schemas.openxmlformats.org/markup-compatibility/2006" xmlns:p159="http://schemas.microsoft.com/office/powerpoint/2015/09/main">
+    <mc:Choice Requires="p159">
+      <p:transition xmlns:p14="http://schemas.microsoft.com/office/powerpoint/2010/main" spd="slow" p14:dur="2000">
+        <p159:morph option="byObject"/>
+      </p:transition>
+    </mc:Choice>
+    <mc:Fallback xmlns="">
+      <p:transition spd="slow">
+        <p:fade/>
+      </p:transition>
+    </mc:Fallback>
+  </mc:AlternateContent>
 </p:sld>
 </file>
 
@@ -5484,7 +6146,7 @@
                 <a:ea typeface="Lato" panose="020F0502020204030203" pitchFamily="34" charset="0"/>
                 <a:cs typeface="Lato" panose="020F0502020204030203" pitchFamily="34" charset="0"/>
               </a:rPr>
-              <a:t> Là công tắc điện tử → có thể khuếch đại tín hiệu hoặc đóng/cắt dòng.</a:t>
+              <a:t> Transistor hoạt động dựa trên việc dòng nhỏ ở chân Base sẽ điều khiển dòng lớn đi qua Collector – Emitter.</a:t>
             </a:r>
           </a:p>
           <a:p>
@@ -5526,7 +6188,7 @@
           <p:nvPr/>
         </p:nvPicPr>
         <p:blipFill>
-          <a:blip r:embed="rId2"/>
+          <a:blip r:embed="rId3"/>
           <a:stretch>
             <a:fillRect/>
           </a:stretch>
@@ -5551,6 +6213,18 @@
   <p:clrMapOvr>
     <a:masterClrMapping/>
   </p:clrMapOvr>
+  <mc:AlternateContent xmlns:mc="http://schemas.openxmlformats.org/markup-compatibility/2006" xmlns:p159="http://schemas.microsoft.com/office/powerpoint/2015/09/main">
+    <mc:Choice Requires="p159">
+      <p:transition xmlns:p14="http://schemas.microsoft.com/office/powerpoint/2010/main" spd="slow" p14:dur="2000">
+        <p159:morph option="byObject"/>
+      </p:transition>
+    </mc:Choice>
+    <mc:Fallback xmlns="">
+      <p:transition spd="slow">
+        <p:fade/>
+      </p:transition>
+    </mc:Fallback>
+  </mc:AlternateContent>
 </p:sld>
 </file>
 
@@ -5647,7 +6321,7 @@
         <p:spPr bwMode="auto">
           <a:xfrm>
             <a:off x="235077" y="1120676"/>
-            <a:ext cx="7609776" cy="2308324"/>
+            <a:ext cx="7483139" cy="2308324"/>
           </a:xfrm>
           <a:prstGeom prst="rect">
             <a:avLst/>
@@ -5774,21 +6448,6 @@
               </a:rPr>
               <a:t>   Ký hiệu:</a:t>
             </a:r>
-            <a:r>
-              <a:rPr kumimoji="0" lang="vi-VN" altLang="vi-VN" sz="1800" b="0" i="0" u="none" strike="noStrike" cap="none" normalizeH="0" baseline="0" dirty="0">
-                <a:ln>
-                  <a:noFill/>
-                </a:ln>
-                <a:solidFill>
-                  <a:schemeClr val="tx1"/>
-                </a:solidFill>
-                <a:effectLst/>
-                <a:latin typeface="Lato" panose="020F0502020204030203" pitchFamily="34" charset="0"/>
-                <a:ea typeface="Lato" panose="020F0502020204030203" pitchFamily="34" charset="0"/>
-                <a:cs typeface="Lato" panose="020F0502020204030203" pitchFamily="34" charset="0"/>
-              </a:rPr>
-              <a:t> Hình công tắc kết hợp cuộn dây.</a:t>
-            </a:r>
           </a:p>
           <a:p>
             <a:pPr marL="0" marR="0" lvl="0" indent="0" algn="l" defTabSz="914400" rtl="0" eaLnBrk="0" fontAlgn="base" latinLnBrk="0" hangingPunct="0">
@@ -6006,7 +6665,7 @@
           <p:nvPr/>
         </p:nvPicPr>
         <p:blipFill>
-          <a:blip r:embed="rId2"/>
+          <a:blip r:embed="rId3"/>
           <a:stretch>
             <a:fillRect/>
           </a:stretch>
@@ -6031,6 +6690,18 @@
   <p:clrMapOvr>
     <a:masterClrMapping/>
   </p:clrMapOvr>
+  <mc:AlternateContent xmlns:mc="http://schemas.openxmlformats.org/markup-compatibility/2006" xmlns:p159="http://schemas.microsoft.com/office/powerpoint/2015/09/main">
+    <mc:Choice Requires="p159">
+      <p:transition xmlns:p14="http://schemas.microsoft.com/office/powerpoint/2010/main" spd="slow" p14:dur="2000">
+        <p159:morph option="byObject"/>
+      </p:transition>
+    </mc:Choice>
+    <mc:Fallback xmlns="">
+      <p:transition spd="slow">
+        <p:fade/>
+      </p:transition>
+    </mc:Fallback>
+  </mc:AlternateContent>
 </p:sld>
 </file>
 
@@ -6168,8 +6839,8 @@
         </p:nvSpPr>
         <p:spPr bwMode="auto">
           <a:xfrm>
-            <a:off x="321493" y="1142584"/>
-            <a:ext cx="8493031" cy="2031325"/>
+            <a:off x="462642" y="1600939"/>
+            <a:ext cx="5227969" cy="1605568"/>
           </a:xfrm>
           <a:prstGeom prst="rect">
             <a:avLst/>
@@ -6209,7 +6880,7 @@
           </a:extLst>
         </p:spPr>
         <p:txBody>
-          <a:bodyPr vert="horz" wrap="none" lIns="91440" tIns="45720" rIns="91440" bIns="45720" numCol="1" anchor="ctr" anchorCtr="0" compatLnSpc="1">
+          <a:bodyPr vert="horz" wrap="square" lIns="91440" tIns="45720" rIns="91440" bIns="45720" numCol="1" anchor="ctr" anchorCtr="0" compatLnSpc="1">
             <a:prstTxWarp prst="textNoShape">
               <a:avLst/>
             </a:prstTxWarp>
@@ -6217,261 +6888,41 @@
           </a:bodyPr>
           <a:lstStyle/>
           <a:p>
-            <a:pPr marL="0" marR="0" lvl="0" indent="0" algn="l" defTabSz="914400" rtl="0" eaLnBrk="0" fontAlgn="base" latinLnBrk="0" hangingPunct="0">
-              <a:lnSpc>
-                <a:spcPct val="100000"/>
-              </a:lnSpc>
-              <a:spcBef>
-                <a:spcPct val="0"/>
-              </a:spcBef>
-              <a:spcAft>
-                <a:spcPct val="0"/>
-              </a:spcAft>
-              <a:buClrTx/>
-              <a:buSzTx/>
-              <a:buFontTx/>
+            <a:r>
+              <a:rPr lang="vi-VN" sz="2000" b="1" dirty="0"/>
+              <a:t>Ví dụ 1: Mạch LED điều khiển bằng transistor</a:t>
+            </a:r>
+          </a:p>
+          <a:p>
+            <a:pPr>
+              <a:buFont typeface="Arial" panose="020B0604020202020204" pitchFamily="34" charset="0"/>
               <a:buChar char="•"/>
-              <a:tabLst/>
             </a:pPr>
             <a:r>
-              <a:rPr kumimoji="0" lang="vi-VN" altLang="vi-VN" sz="1800" b="0" i="0" u="none" strike="noStrike" cap="none" normalizeH="0" baseline="0" dirty="0">
-                <a:ln>
-                  <a:noFill/>
-                </a:ln>
-                <a:solidFill>
-                  <a:schemeClr val="tx1"/>
-                </a:solidFill>
-                <a:effectLst/>
-              </a:rPr>
-              <a:t>   Ví dụ 1: </a:t>
-            </a:r>
-            <a:r>
-              <a:rPr kumimoji="0" lang="vi-VN" altLang="vi-VN" sz="1800" b="1" i="0" u="none" strike="noStrike" cap="none" normalizeH="0" baseline="0" dirty="0">
-                <a:ln>
-                  <a:noFill/>
-                </a:ln>
-                <a:solidFill>
-                  <a:schemeClr val="tx1"/>
-                </a:solidFill>
-                <a:effectLst/>
-              </a:rPr>
-              <a:t>Mạch LED với transistor NPN</a:t>
-            </a:r>
-            <a:endParaRPr kumimoji="0" lang="vi-VN" altLang="vi-VN" sz="1800" b="0" i="0" u="none" strike="noStrike" cap="none" normalizeH="0" baseline="0" dirty="0">
-              <a:ln>
-                <a:noFill/>
-              </a:ln>
-              <a:solidFill>
-                <a:schemeClr val="tx1"/>
-              </a:solidFill>
-              <a:effectLst/>
-            </a:endParaRPr>
-          </a:p>
-          <a:p>
-            <a:pPr marL="0" marR="0" lvl="0" indent="0" algn="l" defTabSz="914400" rtl="0" eaLnBrk="0" fontAlgn="base" latinLnBrk="0" hangingPunct="0">
-              <a:lnSpc>
-                <a:spcPct val="100000"/>
-              </a:lnSpc>
-              <a:spcBef>
-                <a:spcPct val="0"/>
-              </a:spcBef>
-              <a:spcAft>
-                <a:spcPct val="0"/>
-              </a:spcAft>
-              <a:buClrTx/>
-              <a:buSzTx/>
-              <a:buNone/>
-              <a:tabLst/>
-            </a:pPr>
-            <a:r>
-              <a:rPr kumimoji="0" lang="vi-VN" altLang="vi-VN" sz="1800" b="0" i="0" u="none" strike="noStrike" cap="none" normalizeH="0" baseline="0" dirty="0">
-                <a:ln>
-                  <a:noFill/>
-                </a:ln>
-                <a:solidFill>
-                  <a:schemeClr val="tx1"/>
-                </a:solidFill>
-                <a:effectLst/>
-              </a:rPr>
-              <a:t>	Khi có tín hiệu nhỏ ở chân B (Base), transistor sẽ cho dòng chạy qua LED.</a:t>
-            </a:r>
-          </a:p>
-          <a:p>
-            <a:pPr marL="0" marR="0" lvl="0" indent="0" algn="l" defTabSz="914400" rtl="0" eaLnBrk="0" fontAlgn="base" latinLnBrk="0" hangingPunct="0">
-              <a:lnSpc>
-                <a:spcPct val="100000"/>
-              </a:lnSpc>
-              <a:spcBef>
-                <a:spcPct val="0"/>
-              </a:spcBef>
-              <a:spcAft>
-                <a:spcPct val="0"/>
-              </a:spcAft>
-              <a:buClrTx/>
-              <a:buSzTx/>
-              <a:buNone/>
-              <a:tabLst/>
-            </a:pPr>
-            <a:r>
-              <a:rPr lang="vi-VN" altLang="vi-VN" sz="1800" dirty="0"/>
-              <a:t>	</a:t>
-            </a:r>
-            <a:r>
-              <a:rPr kumimoji="0" lang="vi-VN" altLang="vi-VN" sz="1800" b="0" i="0" u="none" strike="noStrike" cap="none" normalizeH="0" baseline="0" dirty="0">
-                <a:ln>
-                  <a:noFill/>
-                </a:ln>
-                <a:solidFill>
-                  <a:schemeClr val="tx1"/>
-                </a:solidFill>
-                <a:effectLst/>
-              </a:rPr>
-              <a:t>Giúp điều khiển LED từ vi điều khiển.</a:t>
-            </a:r>
-          </a:p>
-          <a:p>
-            <a:pPr marL="0" marR="0" lvl="0" indent="0" algn="l" defTabSz="914400" rtl="0" eaLnBrk="0" fontAlgn="base" latinLnBrk="0" hangingPunct="0">
-              <a:lnSpc>
-                <a:spcPct val="100000"/>
-              </a:lnSpc>
-              <a:spcBef>
-                <a:spcPct val="0"/>
-              </a:spcBef>
-              <a:spcAft>
-                <a:spcPct val="0"/>
-              </a:spcAft>
-              <a:buClrTx/>
-              <a:buSzTx/>
-              <a:buFontTx/>
-              <a:buChar char="•"/>
-              <a:tabLst/>
-            </a:pPr>
-            <a:r>
-              <a:rPr kumimoji="0" lang="vi-VN" altLang="vi-VN" sz="1800" b="0" i="0" u="none" strike="noStrike" cap="none" normalizeH="0" baseline="0" dirty="0">
-                <a:ln>
-                  <a:noFill/>
-                </a:ln>
-                <a:solidFill>
-                  <a:schemeClr val="tx1"/>
-                </a:solidFill>
-                <a:effectLst/>
-              </a:rPr>
-              <a:t>   Ví dụ 2: </a:t>
-            </a:r>
-            <a:r>
-              <a:rPr kumimoji="0" lang="vi-VN" altLang="vi-VN" sz="1800" b="1" i="0" u="none" strike="noStrike" cap="none" normalizeH="0" baseline="0" dirty="0">
-                <a:ln>
-                  <a:noFill/>
-                </a:ln>
-                <a:solidFill>
-                  <a:schemeClr val="tx1"/>
-                </a:solidFill>
-                <a:effectLst/>
-              </a:rPr>
-              <a:t>Mạch đèn với relay</a:t>
-            </a:r>
-            <a:endParaRPr kumimoji="0" lang="vi-VN" altLang="vi-VN" sz="1800" b="0" i="0" u="none" strike="noStrike" cap="none" normalizeH="0" baseline="0" dirty="0">
-              <a:ln>
-                <a:noFill/>
-              </a:ln>
-              <a:solidFill>
-                <a:schemeClr val="tx1"/>
-              </a:solidFill>
-              <a:effectLst/>
-            </a:endParaRPr>
-          </a:p>
-          <a:p>
-            <a:pPr marL="0" marR="0" lvl="0" indent="0" algn="l" defTabSz="914400" rtl="0" eaLnBrk="0" fontAlgn="base" latinLnBrk="0" hangingPunct="0">
-              <a:lnSpc>
-                <a:spcPct val="100000"/>
-              </a:lnSpc>
-              <a:spcBef>
-                <a:spcPct val="0"/>
-              </a:spcBef>
-              <a:spcAft>
-                <a:spcPct val="0"/>
-              </a:spcAft>
-              <a:buClrTx/>
-              <a:buSzTx/>
-              <a:buNone/>
-              <a:tabLst/>
-            </a:pPr>
-            <a:r>
-              <a:rPr lang="vi-VN" altLang="vi-VN" sz="1800" dirty="0"/>
-              <a:t>	</a:t>
-            </a:r>
-            <a:r>
-              <a:rPr kumimoji="0" lang="vi-VN" altLang="vi-VN" sz="1800" b="0" i="0" u="none" strike="noStrike" cap="none" normalizeH="0" baseline="0" dirty="0">
-                <a:ln>
-                  <a:noFill/>
-                </a:ln>
-                <a:solidFill>
-                  <a:schemeClr val="tx1"/>
-                </a:solidFill>
-                <a:effectLst/>
-              </a:rPr>
-              <a:t>Arduino (hoặc nguồn 5V) kích relay.</a:t>
-            </a:r>
-          </a:p>
-          <a:p>
-            <a:pPr marL="0" marR="0" lvl="0" indent="0" algn="l" defTabSz="914400" rtl="0" eaLnBrk="0" fontAlgn="base" latinLnBrk="0" hangingPunct="0">
-              <a:lnSpc>
-                <a:spcPct val="100000"/>
-              </a:lnSpc>
-              <a:spcBef>
-                <a:spcPct val="0"/>
-              </a:spcBef>
-              <a:spcAft>
-                <a:spcPct val="0"/>
-              </a:spcAft>
-              <a:buClrTx/>
-              <a:buSzTx/>
-              <a:buNone/>
-              <a:tabLst/>
-            </a:pPr>
-            <a:r>
-              <a:rPr lang="vi-VN" altLang="vi-VN" sz="1800" dirty="0"/>
-              <a:t>	</a:t>
-            </a:r>
-            <a:r>
-              <a:rPr kumimoji="0" lang="vi-VN" altLang="vi-VN" sz="1800" b="0" i="0" u="none" strike="noStrike" cap="none" normalizeH="0" baseline="0" dirty="0">
-                <a:ln>
-                  <a:noFill/>
-                </a:ln>
-                <a:solidFill>
-                  <a:schemeClr val="tx1"/>
-                </a:solidFill>
-                <a:effectLst/>
-              </a:rPr>
-              <a:t>Relay đóng, đèn 220V sáng.</a:t>
-            </a:r>
-          </a:p>
-          <a:p>
-            <a:pPr marL="0" marR="0" lvl="0" indent="0" algn="l" defTabSz="914400" rtl="0" eaLnBrk="0" fontAlgn="base" latinLnBrk="0" hangingPunct="0">
-              <a:lnSpc>
-                <a:spcPct val="100000"/>
-              </a:lnSpc>
-              <a:spcBef>
-                <a:spcPct val="0"/>
-              </a:spcBef>
-              <a:spcAft>
-                <a:spcPct val="0"/>
-              </a:spcAft>
-              <a:buClrTx/>
-              <a:buSzTx/>
-              <a:buFontTx/>
-              <a:buNone/>
-              <a:tabLst/>
-            </a:pPr>
-            <a:endParaRPr kumimoji="0" lang="vi-VN" altLang="vi-VN" sz="1800" b="0" i="0" u="none" strike="noStrike" cap="none" normalizeH="0" baseline="0" dirty="0">
-              <a:ln>
-                <a:noFill/>
-              </a:ln>
-              <a:solidFill>
-                <a:schemeClr val="tx1"/>
-              </a:solidFill>
-              <a:effectLst/>
-            </a:endParaRPr>
+              <a:rPr lang="vi-VN" sz="2000" b="1" dirty="0"/>
+              <a:t>Linh kiện cần:</a:t>
+            </a:r>
+            <a:r>
+              <a:rPr lang="vi-VN" sz="2000" dirty="0"/>
+              <a:t> 1 transistor (loại nào cũng được, NPN dễ dùng), 1 LED, 1 điện trở (220</a:t>
+            </a:r>
+            <a:r>
+              <a:rPr lang="el-GR" sz="2000" dirty="0"/>
+              <a:t>Ω – 1</a:t>
+            </a:r>
+            <a:r>
+              <a:rPr lang="vi-VN" sz="2000" dirty="0"/>
+              <a:t>k</a:t>
+            </a:r>
+            <a:r>
+              <a:rPr lang="el-GR" sz="2000" dirty="0"/>
+              <a:t>Ω), </a:t>
+            </a:r>
+            <a:r>
+              <a:rPr lang="vi-VN" sz="2000"/>
+              <a:t>nguồn 5V</a:t>
+            </a:r>
+            <a:endParaRPr lang="vi-VN" sz="2000" dirty="0"/>
           </a:p>
         </p:txBody>
       </p:sp>
@@ -6485,6 +6936,241 @@
   <p:clrMapOvr>
     <a:masterClrMapping/>
   </p:clrMapOvr>
+  <mc:AlternateContent xmlns:mc="http://schemas.openxmlformats.org/markup-compatibility/2006" xmlns:p159="http://schemas.microsoft.com/office/powerpoint/2015/09/main">
+    <mc:Choice Requires="p159">
+      <p:transition xmlns:p14="http://schemas.microsoft.com/office/powerpoint/2010/main" spd="slow" p14:dur="2000">
+        <p159:morph option="byObject"/>
+      </p:transition>
+    </mc:Choice>
+    <mc:Fallback xmlns="">
+      <p:transition spd="slow">
+        <p:fade/>
+      </p:transition>
+    </mc:Fallback>
+  </mc:AlternateContent>
+</p:sld>
+</file>
+
+<file path=ppt/slides/slide7.xml><?xml version="1.0" encoding="utf-8"?>
+<p:sld xmlns:a="http://schemas.openxmlformats.org/drawingml/2006/main" xmlns:r="http://schemas.openxmlformats.org/officeDocument/2006/relationships" xmlns:p="http://schemas.openxmlformats.org/presentationml/2006/main">
+  <p:cSld>
+    <p:spTree>
+      <p:nvGrpSpPr>
+        <p:cNvPr id="1" name=""/>
+        <p:cNvGrpSpPr/>
+        <p:nvPr/>
+      </p:nvGrpSpPr>
+      <p:grpSpPr>
+        <a:xfrm>
+          <a:off x="0" y="0"/>
+          <a:ext cx="0" cy="0"/>
+          <a:chOff x="0" y="0"/>
+          <a:chExt cx="0" cy="0"/>
+        </a:xfrm>
+      </p:grpSpPr>
+      <p:sp>
+        <p:nvSpPr>
+          <p:cNvPr id="2" name="Slide Number Placeholder 1">
+            <a:extLst>
+              <a:ext uri="{FF2B5EF4-FFF2-40B4-BE49-F238E27FC236}">
+                <a16:creationId xmlns:a16="http://schemas.microsoft.com/office/drawing/2014/main" id="{A6740B87-44E5-4E16-8B82-DD58D6D00CD8}"/>
+              </a:ext>
+            </a:extLst>
+          </p:cNvPr>
+          <p:cNvSpPr>
+            <a:spLocks noGrp="1"/>
+          </p:cNvSpPr>
+          <p:nvPr>
+            <p:ph type="sldNum" sz="quarter" idx="12"/>
+          </p:nvPr>
+        </p:nvSpPr>
+        <p:spPr/>
+        <p:txBody>
+          <a:bodyPr/>
+          <a:lstStyle/>
+          <a:p>
+            <a:fld id="{9EA0BE3B-158A-4EDF-80DC-E394A0D1600F}" type="slidenum">
+              <a:rPr lang="en-US" smtClean="0"/>
+              <a:pPr/>
+              <a:t>7</a:t>
+            </a:fld>
+            <a:endParaRPr lang="en-US" dirty="0"/>
+          </a:p>
+        </p:txBody>
+      </p:sp>
+      <p:sp>
+        <p:nvSpPr>
+          <p:cNvPr id="3" name="Content Placeholder 2">
+            <a:extLst>
+              <a:ext uri="{FF2B5EF4-FFF2-40B4-BE49-F238E27FC236}">
+                <a16:creationId xmlns:a16="http://schemas.microsoft.com/office/drawing/2014/main" id="{66BEB1E0-F62D-420A-A394-BEE1F3D8C7B4}"/>
+              </a:ext>
+            </a:extLst>
+          </p:cNvPr>
+          <p:cNvSpPr>
+            <a:spLocks noGrp="1"/>
+          </p:cNvSpPr>
+          <p:nvPr>
+            <p:ph sz="half" idx="1"/>
+          </p:nvPr>
+        </p:nvSpPr>
+        <p:spPr/>
+        <p:txBody>
+          <a:bodyPr/>
+          <a:lstStyle/>
+          <a:p>
+            <a:r>
+              <a:rPr lang="vi-VN" sz="1800" b="1" dirty="0"/>
+              <a:t>Nguyên lý:</a:t>
+            </a:r>
+            <a:endParaRPr lang="vi-VN" sz="1800" dirty="0"/>
+          </a:p>
+          <a:p>
+            <a:pPr>
+              <a:buFont typeface="Arial" panose="020B0604020202020204" pitchFamily="34" charset="0"/>
+              <a:buChar char="•"/>
+            </a:pPr>
+            <a:r>
+              <a:rPr lang="vi-VN" sz="1800" dirty="0"/>
+              <a:t>Khi có tín hiệu điều khiển nhỏ đưa vào chân Base, transistor sẽ cho dòng đi qua Collector – Emitter.</a:t>
+            </a:r>
+          </a:p>
+          <a:p>
+            <a:pPr>
+              <a:buFont typeface="Arial" panose="020B0604020202020204" pitchFamily="34" charset="0"/>
+              <a:buChar char="•"/>
+            </a:pPr>
+            <a:r>
+              <a:rPr lang="vi-VN" sz="1800" dirty="0"/>
+              <a:t>LED được cấp dòng → LED sáng.</a:t>
+            </a:r>
+          </a:p>
+          <a:p>
+            <a:endParaRPr lang="vi-VN" sz="1800" dirty="0"/>
+          </a:p>
+        </p:txBody>
+      </p:sp>
+      <p:sp>
+        <p:nvSpPr>
+          <p:cNvPr id="5" name="Title 4">
+            <a:extLst>
+              <a:ext uri="{FF2B5EF4-FFF2-40B4-BE49-F238E27FC236}">
+                <a16:creationId xmlns:a16="http://schemas.microsoft.com/office/drawing/2014/main" id="{CFA603C6-3FA8-4379-A375-705DC01A4E87}"/>
+              </a:ext>
+            </a:extLst>
+          </p:cNvPr>
+          <p:cNvSpPr>
+            <a:spLocks noGrp="1"/>
+          </p:cNvSpPr>
+          <p:nvPr>
+            <p:ph type="title"/>
+          </p:nvPr>
+        </p:nvSpPr>
+        <p:spPr/>
+        <p:txBody>
+          <a:bodyPr/>
+          <a:lstStyle/>
+          <a:p>
+            <a:r>
+              <a:rPr lang="en-US" dirty="0" err="1"/>
+              <a:t>Vẽ</a:t>
+            </a:r>
+            <a:r>
+              <a:rPr lang="en-US" dirty="0"/>
+              <a:t> </a:t>
+            </a:r>
+            <a:r>
+              <a:rPr lang="en-US" dirty="0" err="1"/>
+              <a:t>sơ</a:t>
+            </a:r>
+            <a:r>
+              <a:rPr lang="en-US" dirty="0"/>
+              <a:t> </a:t>
+            </a:r>
+            <a:r>
+              <a:rPr lang="en-US" dirty="0" err="1"/>
+              <a:t>đồ</a:t>
+            </a:r>
+            <a:r>
+              <a:rPr lang="en-US" dirty="0"/>
+              <a:t> </a:t>
+            </a:r>
+            <a:r>
+              <a:rPr lang="en-US" dirty="0" err="1"/>
+              <a:t>mạch</a:t>
+            </a:r>
+            <a:r>
+              <a:rPr lang="en-US" dirty="0"/>
+              <a:t> </a:t>
+            </a:r>
+            <a:r>
+              <a:rPr lang="en-US" dirty="0" err="1"/>
+              <a:t>đơn</a:t>
+            </a:r>
+            <a:r>
+              <a:rPr lang="en-US" dirty="0"/>
+              <a:t> </a:t>
+            </a:r>
+            <a:r>
+              <a:rPr lang="en-US" dirty="0" err="1"/>
+              <a:t>giản</a:t>
+            </a:r>
+            <a:endParaRPr lang="vi-VN" dirty="0"/>
+          </a:p>
+        </p:txBody>
+      </p:sp>
+      <p:pic>
+        <p:nvPicPr>
+          <p:cNvPr id="7" name="Picture 6">
+            <a:extLst>
+              <a:ext uri="{FF2B5EF4-FFF2-40B4-BE49-F238E27FC236}">
+                <a16:creationId xmlns:a16="http://schemas.microsoft.com/office/drawing/2014/main" id="{CF9A22FC-24A8-4F18-BAA1-9230CBFD9856}"/>
+              </a:ext>
+            </a:extLst>
+          </p:cNvPr>
+          <p:cNvPicPr>
+            <a:picLocks noChangeAspect="1"/>
+          </p:cNvPicPr>
+          <p:nvPr/>
+        </p:nvPicPr>
+        <p:blipFill>
+          <a:blip r:embed="rId2"/>
+          <a:stretch>
+            <a:fillRect/>
+          </a:stretch>
+        </p:blipFill>
+        <p:spPr>
+          <a:xfrm>
+            <a:off x="3884666" y="2975733"/>
+            <a:ext cx="5259334" cy="3468295"/>
+          </a:xfrm>
+          <a:prstGeom prst="rect">
+            <a:avLst/>
+          </a:prstGeom>
+        </p:spPr>
+      </p:pic>
+    </p:spTree>
+    <p:extLst>
+      <p:ext uri="{BB962C8B-B14F-4D97-AF65-F5344CB8AC3E}">
+        <p14:creationId xmlns:p14="http://schemas.microsoft.com/office/powerpoint/2010/main" val="1007850042"/>
+      </p:ext>
+    </p:extLst>
+  </p:cSld>
+  <p:clrMapOvr>
+    <a:masterClrMapping/>
+  </p:clrMapOvr>
+  <mc:AlternateContent xmlns:mc="http://schemas.openxmlformats.org/markup-compatibility/2006" xmlns:p159="http://schemas.microsoft.com/office/powerpoint/2015/09/main">
+    <mc:Choice Requires="p159">
+      <p:transition xmlns:p14="http://schemas.microsoft.com/office/powerpoint/2010/main" spd="slow" p14:dur="2000">
+        <p159:morph option="byObject"/>
+      </p:transition>
+    </mc:Choice>
+    <mc:Fallback xmlns="">
+      <p:transition spd="slow">
+        <p:fade/>
+      </p:transition>
+    </mc:Fallback>
+  </mc:AlternateContent>
 </p:sld>
 </file>
 

</xml_diff>